<commit_message>
docs: fix MongoDB README repo structure, add MongoDB lab test results, update slide decks
</commit_message>
<xml_diff>
--- a/MongoDB-Labs/MongoDB_Labs_Overview.pptx
+++ b/MongoDB-Labs/MongoDB_Labs_Overview.pptx
@@ -12396,15 +12396,13 @@
               <a:buNone/>
             </a:pPr>
             <a:r>
-              <a:rPr lang="en-US" sz="1050" dirty="0">
+              <a:rPr sz="1050">
                 <a:solidFill>
                   <a:srgbClr val="023430"/>
                 </a:solidFill>
-                <a:latin typeface="Calibri" pitchFamily="34" charset="0"/>
-                <a:ea typeface="Calibri" pitchFamily="34" charset="-122"/>
-                <a:cs typeface="Calibri" pitchFamily="34" charset="-120"/>
-              </a:rPr>
-              <a:t>One big project (planned)</a:t>
+                <a:latin typeface="Calibri"/>
+              </a:rPr>
+              <a:t>One big project (documented)</a:t>
             </a:r>
             <a:endParaRPr lang="en-US" sz="1050" dirty="0"/>
           </a:p>
@@ -12438,15 +12436,13 @@
               <a:buNone/>
             </a:pPr>
             <a:r>
-              <a:rPr lang="en-US" sz="1350" dirty="0">
+              <a:rPr sz="1350">
                 <a:solidFill>
                   <a:srgbClr val="0B2B22"/>
                 </a:solidFill>
-                <a:latin typeface="Calibri" pitchFamily="34" charset="0"/>
-                <a:ea typeface="Calibri" pitchFamily="34" charset="-122"/>
-                <a:cs typeface="Calibri" pitchFamily="34" charset="-120"/>
-              </a:rPr>
-              <a:t>The full path: Beginner labs teach you to connect and read/write data → Intermediate labs teach grouping data and designing your schema → Advanced labs teach safe, all-or-nothing saves and running on many servers → the Capstone (Lab 7) is documented as the final goal, but is not built yet — it is where these skills would be used to build memory for a real AI agent.</a:t>
+                <a:latin typeface="Calibri"/>
+              </a:rPr>
+              <a:t>The full path: Beginner labs teach you to connect and read/write data → Intermediate labs teach grouping data and designing your schema → Advanced labs teach safe, all-or-nothing saves and running on many servers → the Capstone (Lab 7) is provided as a documented brief, assignment, and test — you build the notebook yourself. It is where these skills come together to build memory for a real AI agent.</a:t>
             </a:r>
             <a:endParaRPr lang="en-US" sz="1350" dirty="0"/>
           </a:p>
@@ -14961,37 +14957,26 @@
               <a:buNone/>
             </a:pPr>
             <a:r>
-              <a:rPr lang="en-US" sz="1150" dirty="0">
+              <a:rPr sz="1150">
                 <a:solidFill>
                   <a:srgbClr val="0B2B22"/>
                 </a:solidFill>
-                <a:latin typeface="Calibri" pitchFamily="34" charset="0"/>
-                <a:ea typeface="Calibri" pitchFamily="34" charset="-122"/>
-                <a:cs typeface="Calibri" pitchFamily="34" charset="-120"/>
+                <a:latin typeface="Calibri"/>
               </a:rPr>
               <a:t>AI Agent Memory Service</a:t>
             </a:r>
             <a:endParaRPr lang="en-US" sz="1150" dirty="0"/>
           </a:p>
           <a:p>
-            <a:pPr marL="0" indent="0">
-              <a:lnSpc>
-                <a:spcPct val="115000"/>
-              </a:lnSpc>
-              <a:buNone/>
-            </a:pPr>
-            <a:r>
-              <a:rPr lang="en-US" sz="1150" dirty="0">
+            <a:r>
+              <a:rPr sz="1150">
                 <a:solidFill>
                   <a:srgbClr val="0B2B22"/>
                 </a:solidFill>
-                <a:latin typeface="Calibri" pitchFamily="34" charset="0"/>
-                <a:ea typeface="Calibri" pitchFamily="34" charset="-122"/>
-                <a:cs typeface="Calibri" pitchFamily="34" charset="-120"/>
-              </a:rPr>
-              <a:t>(Capstone — planned only)</a:t>
-            </a:r>
-            <a:endParaRPr lang="en-US" sz="1150" dirty="0"/>
+                <a:latin typeface="Calibri"/>
+              </a:rPr>
+              <a:t>(Capstone — documented, you build it)</a:t>
+            </a:r>
           </a:p>
         </p:txBody>
       </p:sp>
@@ -15261,185 +15246,136 @@
               <a:buNone/>
             </a:pPr>
             <a:r>
-              <a:rPr lang="en-US" sz="1400" dirty="0">
+              <a:rPr sz="1400">
                 <a:solidFill>
                   <a:srgbClr val="00ED64"/>
                 </a:solidFill>
-                <a:latin typeface="Courier New" pitchFamily="34" charset="0"/>
-                <a:ea typeface="Courier New" pitchFamily="34" charset="-122"/>
-                <a:cs typeface="Courier New" pitchFamily="34" charset="-120"/>
-              </a:rPr>
-              <a:t>MongoDB-Labs/
-</a:t>
+                <a:latin typeface="Courier New"/>
+              </a:rPr>
+              <a:t>MongoDB-Labs/</a:t>
             </a:r>
             <a:endParaRPr lang="en-US" sz="1400" dirty="0"/>
           </a:p>
           <a:p>
-            <a:pPr marL="0" indent="0">
-              <a:lnSpc>
-                <a:spcPct val="130000"/>
-              </a:lnSpc>
-              <a:buNone/>
-            </a:pPr>
-            <a:r>
-              <a:rPr lang="en-US" sz="1400" dirty="0">
+            <a:r>
+              <a:rPr sz="1400">
                 <a:solidFill>
                   <a:srgbClr val="00ED64"/>
                 </a:solidFill>
-                <a:latin typeface="Courier New" pitchFamily="34" charset="0"/>
-                <a:ea typeface="Courier New" pitchFamily="34" charset="-122"/>
-                <a:cs typeface="Courier New" pitchFamily="34" charset="-120"/>
-              </a:rPr>
-              <a:t>├── Lab 1 - &lt;Title&gt;/
-</a:t>
-            </a:r>
-            <a:endParaRPr lang="en-US" sz="1400" dirty="0"/>
-          </a:p>
-          <a:p>
-            <a:pPr marL="0" indent="0">
-              <a:lnSpc>
-                <a:spcPct val="130000"/>
-              </a:lnSpc>
-              <a:buNone/>
-            </a:pPr>
-            <a:r>
-              <a:rPr lang="en-US" sz="1400" dirty="0">
+                <a:latin typeface="Courier New"/>
+              </a:rPr>
+              <a:t>├── Lab 1 - Student Records Lookup/</a:t>
+            </a:r>
+          </a:p>
+          <a:p>
+            <a:r>
+              <a:rPr sz="1400">
                 <a:solidFill>
                   <a:srgbClr val="00ED64"/>
                 </a:solidFill>
-                <a:latin typeface="Courier New" pitchFamily="34" charset="0"/>
-                <a:ea typeface="Courier New" pitchFamily="34" charset="-122"/>
-                <a:cs typeface="Courier New" pitchFamily="34" charset="-120"/>
-              </a:rPr>
-              <a:t>│   ├── &lt;notebook&gt;.ipynb
-</a:t>
-            </a:r>
-            <a:endParaRPr lang="en-US" sz="1400" dirty="0"/>
-          </a:p>
-          <a:p>
-            <a:pPr marL="0" indent="0">
-              <a:lnSpc>
-                <a:spcPct val="130000"/>
-              </a:lnSpc>
-              <a:buNone/>
-            </a:pPr>
-            <a:r>
-              <a:rPr lang="en-US" sz="1400" dirty="0">
+                <a:latin typeface="Courier New"/>
+              </a:rPr>
+              <a:t>│   ├── lab-1-student-records-lookup.ipynb</a:t>
+            </a:r>
+          </a:p>
+          <a:p>
+            <a:r>
+              <a:rPr sz="1400">
                 <a:solidFill>
                   <a:srgbClr val="00ED64"/>
                 </a:solidFill>
-                <a:latin typeface="Courier New" pitchFamily="34" charset="0"/>
-                <a:ea typeface="Courier New" pitchFamily="34" charset="-122"/>
-                <a:cs typeface="Courier New" pitchFamily="34" charset="-120"/>
-              </a:rPr>
-              <a:t>│   ├── &lt;notes&gt;.md
-</a:t>
-            </a:r>
-            <a:endParaRPr lang="en-US" sz="1400" dirty="0"/>
-          </a:p>
-          <a:p>
-            <a:pPr marL="0" indent="0">
-              <a:lnSpc>
-                <a:spcPct val="130000"/>
-              </a:lnSpc>
-              <a:buNone/>
-            </a:pPr>
-            <a:r>
-              <a:rPr lang="en-US" sz="1400" dirty="0">
+                <a:latin typeface="Courier New"/>
+              </a:rPr>
+              <a:t>│   ├── lab-1-student-records-lookup.md</a:t>
+            </a:r>
+          </a:p>
+          <a:p>
+            <a:r>
+              <a:rPr sz="1400">
                 <a:solidFill>
                   <a:srgbClr val="00ED64"/>
                 </a:solidFill>
-                <a:latin typeface="Courier New" pitchFamily="34" charset="0"/>
-                <a:ea typeface="Courier New" pitchFamily="34" charset="-122"/>
-                <a:cs typeface="Courier New" pitchFamily="34" charset="-120"/>
-              </a:rPr>
-              <a:t>│   └── &lt;assignment&gt;.md
-</a:t>
-            </a:r>
-            <a:endParaRPr lang="en-US" sz="1400" dirty="0"/>
-          </a:p>
-          <a:p>
-            <a:pPr marL="0" indent="0">
-              <a:lnSpc>
-                <a:spcPct val="130000"/>
-              </a:lnSpc>
-              <a:buNone/>
-            </a:pPr>
-            <a:r>
-              <a:rPr lang="en-US" sz="1400" dirty="0">
+                <a:latin typeface="Courier New"/>
+              </a:rPr>
+              <a:t>│   ├── lab-1-student-records-lookup-assignment.md</a:t>
+            </a:r>
+          </a:p>
+          <a:p>
+            <a:r>
+              <a:rPr sz="1400">
                 <a:solidFill>
                   <a:srgbClr val="00ED64"/>
                 </a:solidFill>
-                <a:latin typeface="Courier New" pitchFamily="34" charset="0"/>
-                <a:ea typeface="Courier New" pitchFamily="34" charset="-122"/>
-                <a:cs typeface="Courier New" pitchFamily="34" charset="-120"/>
-              </a:rPr>
-              <a:t>├── Lab 2 - &lt;Title&gt;/
-</a:t>
-            </a:r>
-            <a:endParaRPr lang="en-US" sz="1400" dirty="0"/>
-          </a:p>
-          <a:p>
-            <a:pPr marL="0" indent="0">
-              <a:lnSpc>
-                <a:spcPct val="130000"/>
-              </a:lnSpc>
-              <a:buNone/>
-            </a:pPr>
-            <a:r>
-              <a:rPr lang="en-US" sz="1400" dirty="0">
+                <a:latin typeface="Courier New"/>
+              </a:rPr>
+              <a:t>│   └── test_lab1_student_records_lookup.py</a:t>
+            </a:r>
+          </a:p>
+          <a:p>
+            <a:r>
+              <a:rPr sz="1400">
                 <a:solidFill>
                   <a:srgbClr val="00ED64"/>
                 </a:solidFill>
-                <a:latin typeface="Courier New" pitchFamily="34" charset="0"/>
-                <a:ea typeface="Courier New" pitchFamily="34" charset="-122"/>
-                <a:cs typeface="Courier New" pitchFamily="34" charset="-120"/>
-              </a:rPr>
-              <a:t>│   └── ...
-</a:t>
-            </a:r>
-            <a:endParaRPr lang="en-US" sz="1400" dirty="0"/>
-          </a:p>
-          <a:p>
-            <a:pPr marL="0" indent="0">
-              <a:lnSpc>
-                <a:spcPct val="130000"/>
-              </a:lnSpc>
-              <a:buNone/>
-            </a:pPr>
-            <a:r>
-              <a:rPr lang="en-US" sz="1400" dirty="0">
+                <a:latin typeface="Courier New"/>
+              </a:rPr>
+              <a:t>├── Lab 2 - Student Enrollment Tracker/</a:t>
+            </a:r>
+          </a:p>
+          <a:p>
+            <a:r>
+              <a:rPr sz="1400">
                 <a:solidFill>
                   <a:srgbClr val="00ED64"/>
                 </a:solidFill>
-                <a:latin typeface="Courier New" pitchFamily="34" charset="0"/>
-                <a:ea typeface="Courier New" pitchFamily="34" charset="-122"/>
-                <a:cs typeface="Courier New" pitchFamily="34" charset="-120"/>
-              </a:rPr>
-              <a:t>├── .env
-</a:t>
-            </a:r>
-            <a:endParaRPr lang="en-US" sz="1400" dirty="0"/>
-          </a:p>
-          <a:p>
-            <a:pPr marL="0" indent="0">
-              <a:lnSpc>
-                <a:spcPct val="130000"/>
-              </a:lnSpc>
-              <a:buNone/>
-            </a:pPr>
-            <a:r>
-              <a:rPr lang="en-US" sz="1400" dirty="0">
+                <a:latin typeface="Courier New"/>
+              </a:rPr>
+              <a:t>│   └── ... (same four files)</a:t>
+            </a:r>
+          </a:p>
+          <a:p>
+            <a:r>
+              <a:rPr sz="1400">
                 <a:solidFill>
                   <a:srgbClr val="00ED64"/>
                 </a:solidFill>
-                <a:latin typeface="Courier New" pitchFamily="34" charset="0"/>
-                <a:ea typeface="Courier New" pitchFamily="34" charset="-122"/>
-                <a:cs typeface="Courier New" pitchFamily="34" charset="-120"/>
+                <a:latin typeface="Courier New"/>
+              </a:rPr>
+              <a:t>├── ... Labs 3-6, same pattern</a:t>
+            </a:r>
+          </a:p>
+          <a:p>
+            <a:r>
+              <a:rPr sz="1400">
+                <a:solidFill>
+                  <a:srgbClr val="00ED64"/>
+                </a:solidFill>
+                <a:latin typeface="Courier New"/>
+              </a:rPr>
+              <a:t>├── Lab 7 - AI Agent Memory Service/   (documented capstone — you build the notebook)</a:t>
+            </a:r>
+          </a:p>
+          <a:p>
+            <a:r>
+              <a:rPr sz="1400">
+                <a:solidFill>
+                  <a:srgbClr val="00ED64"/>
+                </a:solidFill>
+                <a:latin typeface="Courier New"/>
+              </a:rPr>
+              <a:t>├── .env</a:t>
+            </a:r>
+          </a:p>
+          <a:p>
+            <a:r>
+              <a:rPr sz="1400">
+                <a:solidFill>
+                  <a:srgbClr val="00ED64"/>
+                </a:solidFill>
+                <a:latin typeface="Courier New"/>
               </a:rPr>
               <a:t>└── README.md</a:t>
             </a:r>
-            <a:endParaRPr lang="en-US" sz="1400" dirty="0"/>
           </a:p>
         </p:txBody>
       </p:sp>
@@ -15515,57 +15451,13 @@
               <a:buNone/>
             </a:pPr>
             <a:r>
-              <a:rPr lang="en-US" sz="1280" dirty="0">
+              <a:rPr sz="1280">
                 <a:solidFill>
                   <a:srgbClr val="0B2B22"/>
                 </a:solidFill>
-                <a:latin typeface="Calibri" pitchFamily="34" charset="0"/>
-                <a:ea typeface="Calibri" pitchFamily="34" charset="-122"/>
-                <a:cs typeface="Calibri" pitchFamily="34" charset="-120"/>
-              </a:rPr>
-              <a:t>Each lab has its own folder with exactly 3 files: a notebook you run, a notes file you read if a step needs more explaining, and an assignment file to check what you learned.
-</a:t>
-            </a:r>
-            <a:endParaRPr lang="en-US" sz="1280" dirty="0"/>
-          </a:p>
-          <a:p>
-            <a:pPr marL="0" indent="0">
-              <a:lnSpc>
-                <a:spcPct val="132000"/>
-              </a:lnSpc>
-              <a:buNone/>
-            </a:pPr>
-            <a:r>
-              <a:rPr lang="en-US" sz="1280" dirty="0">
-                <a:solidFill>
-                  <a:srgbClr val="0B2B22"/>
-                </a:solidFill>
-                <a:latin typeface="Calibri" pitchFamily="34" charset="0"/>
-                <a:ea typeface="Calibri" pitchFamily="34" charset="-122"/>
-                <a:cs typeface="Calibri" pitchFamily="34" charset="-120"/>
-              </a:rPr>
-              <a:t>The .env file lives once, at the very top of the whole project — not inside each lab folder.
-</a:t>
-            </a:r>
-            <a:endParaRPr lang="en-US" sz="1280" dirty="0"/>
-          </a:p>
-          <a:p>
-            <a:pPr marL="0" indent="0">
-              <a:lnSpc>
-                <a:spcPct val="132000"/>
-              </a:lnSpc>
-              <a:buNone/>
-            </a:pPr>
-            <a:r>
-              <a:rPr lang="en-US" sz="1280" dirty="0">
-                <a:solidFill>
-                  <a:srgbClr val="0B2B22"/>
-                </a:solidFill>
-                <a:latin typeface="Calibri" pitchFamily="34" charset="0"/>
-                <a:ea typeface="Calibri" pitchFamily="34" charset="-122"/>
-                <a:cs typeface="Calibri" pitchFamily="34" charset="-120"/>
-              </a:rPr>
-              <a:t>Every lab folder shares that one same .env file, so you only ever set up your Atlas connection once.</a:t>
+                <a:latin typeface="Calibri"/>
+              </a:rPr>
+              <a:t>Each lab has its own folder with four files: a notebook you run, a notes file you read if a step needs more explaining, an assignment file to check what you learned, and a test file that grades your work. The .env file lives once, at the very top of the whole project — not inside each lab folder. Every lab folder shares that one same .env file, so you only ever set up your Atlas connection once.</a:t>
             </a:r>
             <a:endParaRPr lang="en-US" sz="1280" dirty="0"/>
           </a:p>

</xml_diff>